<commit_message>
Oct 30 class: retimed deck (35 min teach + 10 min Q&A) + updated speaker notes
</commit_message>
<xml_diff>
--- a/assets/SSI-SSDI-DAC-Class-Oct30.pptx
+++ b/assets/SSI-SSDI-DAC-Class-Oct30.pptx
@@ -532,7 +532,7 @@
           </a:p>
           <a:p>
             <a:r>
-              <a:t>House rules: "Keep questions for the end, or drop them in the chat. And please keep your child's private details private tonight — no names or medical details out loud. Private questions are what my free consultation is for."</a:t>
+              <a:t>House rules: "We teach for 35 minutes, and the last 10 minutes are all for your questions — I'll start with the questions families sent when they registered, then open the floor. And please keep your child's private details private tonight — no names or medical details out loud. Private questions are what my free consultation is for."</a:t>
             </a:r>
           </a:p>
           <a:p>
@@ -607,7 +607,7 @@
           <a:lstStyle/>
           <a:p>
             <a:r>
-              <a:t>[Minutes 29–33 · THE MONEY / WORK TEST]</a:t>
+              <a:t>[Minutes 24–27 · THE MONEY / WORK TEST]</a:t>
             </a:r>
           </a:p>
           <a:p>
@@ -698,7 +698,7 @@
           <a:lstStyle/>
           <a:p>
             <a:r>
-              <a:t>[Minutes 33–37 · FIRST STEPS]</a:t>
+              <a:t>[Minutes 27–30 · FIRST STEPS]</a:t>
             </a:r>
           </a:p>
           <a:p>
@@ -789,7 +789,7 @@
           <a:lstStyle/>
           <a:p>
             <a:r>
-              <a:t>[Minutes 37–39 · THE FOLDER]</a:t>
+              <a:t>[Minutes 30–32 · THE FOLDER]</a:t>
             </a:r>
           </a:p>
           <a:p>
@@ -880,7 +880,7 @@
           <a:lstStyle/>
           <a:p>
             <a:r>
-              <a:t>[Minutes 39–41 · TIPS THAT HELP]</a:t>
+              <a:t>[Minutes 32–33 · TIPS THAT HELP]</a:t>
             </a:r>
           </a:p>
           <a:p>
@@ -966,7 +966,7 @@
           <a:lstStyle/>
           <a:p>
             <a:r>
-              <a:t>[Minutes 41–43 · MISTAKES — quick and punchy]</a:t>
+              <a:t>[Minutes 33–34 · MISTAKES — quick and punchy]</a:t>
             </a:r>
           </a:p>
           <a:p>
@@ -1052,7 +1052,7 @@
           <a:lstStyle/>
           <a:p>
             <a:r>
-              <a:t>[Minutes 43–44 · THE INVITATION — warm, no pressure]</a:t>
+              <a:t>[Minutes 34–35 · THE INVITATION — warm, no pressure]</a:t>
             </a:r>
           </a:p>
           <a:p>
@@ -1143,17 +1143,27 @@
           <a:lstStyle/>
           <a:p>
             <a:r>
-              <a:t>[Minutes 44–45 · CLOSE + QUESTIONS]</a:t>
-            </a:r>
-          </a:p>
-          <a:p>
-            <a:r>
-              <a:t>Open the floor: "What questions do you have? General questions are perfect here. For your family's private details, that's what the free consultation is for."</a:t>
-            </a:r>
-          </a:p>
-          <a:p>
-            <a:r>
-              <a:t>THE ASK — say it warmly and exactly: "If this class helped you, do two things tonight. One: book your free consultation at southernoakfw.org/book. Two: tell one parent you know — families find help through other families."</a:t>
+              <a:t>[Minutes 35–45 · QUESTIONS + CLOSE — 10 full minutes]</a:t>
+            </a:r>
+          </a:p>
+          <a:p>
+            <a:r>
+              <a:t>Start with the questions families sent when they registered: "When you registered, some of you sent me your questions — let's start there." Read each one out loud and answer in plain words, one at a time.</a:t>
+            </a:r>
+          </a:p>
+          <a:p>
+            <a:r>
+              <a:t>Then open the floor: "What other questions do you have? General questions are perfect here. For your family's private details, that's what the free consultation is for."</a:t>
+            </a:r>
+          </a:p>
+          <a:p>
+            <a:r>
+              <a:t>Keep answers short — about a minute each — so everyone gets a turn. If a question is long or private: "That one deserves a real talk — book the free consultation and we will go through it together."</a:t>
+            </a:r>
+          </a:p>
+          <a:p>
+            <a:r>
+              <a:t>Last 2 minutes — THE ASK, say it warmly and exactly: "If this class helped you, do two things tonight. One: book your free consultation at southernoakfw.org/book. Two: tell one parent you know — families find help through other families."</a:t>
             </a:r>
           </a:p>
           <a:p>
@@ -1171,7 +1181,6 @@
               <a:t>After class: send Rio the names of anyone who asked to book, and Rio prepares the follow-ups.</a:t>
             </a:r>
           </a:p>
-          <a:p/>
         </p:txBody>
       </p:sp>
       <p:sp>
@@ -1325,7 +1334,7 @@
           <a:lstStyle/>
           <a:p>
             <a:r>
-              <a:t>[Minutes 5–7 · ROAD MAP]</a:t>
+              <a:t>[Minutes 5–6 · ROAD MAP]</a:t>
             </a:r>
           </a:p>
           <a:p>
@@ -1411,7 +1420,7 @@
           <a:lstStyle/>
           <a:p>
             <a:r>
-              <a:t>[Minutes 7–12 · WHAT IS SSI]</a:t>
+              <a:t>[Minutes 6–10 · WHAT IS SSI]</a:t>
             </a:r>
           </a:p>
           <a:p>
@@ -1507,7 +1516,7 @@
           <a:lstStyle/>
           <a:p>
             <a:r>
-              <a:t>[Minutes 12–16 · WHAT IS SSDI]</a:t>
+              <a:t>[Minutes 10–13 · WHAT IS SSDI]</a:t>
             </a:r>
           </a:p>
           <a:p>
@@ -1598,7 +1607,7 @@
           <a:lstStyle/>
           <a:p>
             <a:r>
-              <a:t>[Minutes 16–21 · WHAT IS DAC]</a:t>
+              <a:t>[Minutes 13–17 · WHAT IS DAC]</a:t>
             </a:r>
           </a:p>
           <a:p>
@@ -1689,7 +1698,7 @@
           <a:lstStyle/>
           <a:p>
             <a:r>
-              <a:t>[Minutes 21–23 · THE PICTURE ON ONE SLIDE]</a:t>
+              <a:t>[Minutes 17–19 · THE PICTURE ON ONE SLIDE]</a:t>
             </a:r>
           </a:p>
           <a:p>
@@ -1780,7 +1789,7 @@
           <a:lstStyle/>
           <a:p>
             <a:r>
-              <a:t>[Minutes 23–25 · THE TWO TESTS]</a:t>
+              <a:t>[Minutes 19–21 · THE TWO TESTS]</a:t>
             </a:r>
           </a:p>
           <a:p>
@@ -1866,7 +1875,7 @@
           <a:lstStyle/>
           <a:p>
             <a:r>
-              <a:t>[Minutes 25–29 · THE DISABILITY TEST]</a:t>
+              <a:t>[Minutes 21–24 · THE DISABILITY TEST]</a:t>
             </a:r>
           </a:p>
           <a:p>

</xml_diff>